<commit_message>
fix(slides): sync presentation slides with demo script and app state
- Update test count to 55 tests passed across Slide 1, 3, 14
- Update Slide 3 to segmented control model selection
- Align Slide 12 with 4 current Streamlit pages and segmented control UI mockup
- Clarify TF-IDF feature importance vs causal XAI on Slide 13
- Correct ablation metric for Text + Lexicon + Aspect to 0.7433 on Slide 6
- Tune Slide 5 EDA chart caption layout and spacing
- Use negation detection terminology on Slide 10
- Update Slide 15 transition to live demo by Pham Thanh Trung
- Add .agents/ to .gitignore
</commit_message>
<xml_diff>
--- a/reports/slides/NLP_ITviec_Sentiment_Slides.pptx
+++ b/reports/slides/NLP_ITviec_Sentiment_Slides.pptx
@@ -7130,7 +7130,7 @@
                 </a:solidFill>
                 <a:latin typeface="Segoe UI"/>
               </a:rPr>
-              <a:t>43/43</a:t>
+              <a:t>55/55</a:t>
             </a:r>
           </a:p>
         </p:txBody>
@@ -7169,7 +7169,7 @@
                 </a:solidFill>
                 <a:latin typeface="Segoe UI"/>
               </a:rPr>
-              <a:t>unit test</a:t>
+              <a:t>test passed</a:t>
             </a:r>
           </a:p>
         </p:txBody>
@@ -8157,7 +8157,7 @@
                 </a:solidFill>
                 <a:latin typeface="Segoe UI"/>
               </a:rPr>
-              <a:t>Tiêu cực (71.1%) — bóc tách 3 cụm từ XAI</a:t>
+              <a:t>Tiêu cực (71.1%) — phát hiện 3 cụm phủ định</a:t>
             </a:r>
           </a:p>
         </p:txBody>
@@ -8408,8 +8408,8 @@
         </p:nvSpPr>
         <p:spPr>
           <a:xfrm>
-            <a:off x="6729984" y="4096512"/>
-            <a:ext cx="4590288" cy="256032"/>
+            <a:off x="6729984" y="3986784"/>
+            <a:ext cx="4590288" cy="347472"/>
           </a:xfrm>
           <a:prstGeom prst="rect">
             <a:avLst/>
@@ -8424,11 +8424,11 @@
           <a:p>
             <a:pPr algn="ctr">
               <a:lnSpc>
-                <a:spcPct val="100000"/>
+                <a:spcPct val="105000"/>
               </a:lnSpc>
             </a:pPr>
             <a:r>
-              <a:rPr sz="1050" b="0">
+              <a:rPr sz="950" b="0">
                 <a:solidFill>
                   <a:srgbClr val="333A44"/>
                 </a:solidFill>
@@ -9334,8 +9334,8 @@
         </p:nvSpPr>
         <p:spPr>
           <a:xfrm>
-            <a:off x="630936" y="3273552"/>
-            <a:ext cx="2487168" cy="256032"/>
+            <a:off x="630936" y="3163824"/>
+            <a:ext cx="2487168" cy="347472"/>
           </a:xfrm>
           <a:prstGeom prst="rect">
             <a:avLst/>
@@ -9350,11 +9350,11 @@
           <a:p>
             <a:pPr algn="ctr">
               <a:lnSpc>
-                <a:spcPct val="100000"/>
+                <a:spcPct val="105000"/>
               </a:lnSpc>
             </a:pPr>
             <a:r>
-              <a:rPr sz="1050" b="0">
+              <a:rPr sz="950" b="0">
                 <a:solidFill>
                   <a:srgbClr val="333A44"/>
                 </a:solidFill>
@@ -9443,8 +9443,8 @@
         </p:nvSpPr>
         <p:spPr>
           <a:xfrm>
-            <a:off x="630936" y="5468112"/>
-            <a:ext cx="2487168" cy="256032"/>
+            <a:off x="630936" y="5358384"/>
+            <a:ext cx="2487168" cy="347472"/>
           </a:xfrm>
           <a:prstGeom prst="rect">
             <a:avLst/>
@@ -9459,11 +9459,11 @@
           <a:p>
             <a:pPr algn="ctr">
               <a:lnSpc>
-                <a:spcPct val="100000"/>
+                <a:spcPct val="105000"/>
               </a:lnSpc>
             </a:pPr>
             <a:r>
-              <a:rPr sz="1050" b="0">
+              <a:rPr sz="950" b="0">
                 <a:solidFill>
                   <a:srgbClr val="333A44"/>
                 </a:solidFill>
@@ -9552,8 +9552,8 @@
         </p:nvSpPr>
         <p:spPr>
           <a:xfrm>
-            <a:off x="3557016" y="3273552"/>
-            <a:ext cx="3904488" cy="256032"/>
+            <a:off x="3557016" y="3163824"/>
+            <a:ext cx="3904488" cy="347472"/>
           </a:xfrm>
           <a:prstGeom prst="rect">
             <a:avLst/>
@@ -9568,11 +9568,11 @@
           <a:p>
             <a:pPr algn="ctr">
               <a:lnSpc>
-                <a:spcPct val="100000"/>
+                <a:spcPct val="105000"/>
               </a:lnSpc>
             </a:pPr>
             <a:r>
-              <a:rPr sz="1050" b="0">
+              <a:rPr sz="950" b="0">
                 <a:solidFill>
                   <a:srgbClr val="333A44"/>
                 </a:solidFill>
@@ -9661,8 +9661,8 @@
         </p:nvSpPr>
         <p:spPr>
           <a:xfrm>
-            <a:off x="3557016" y="5468112"/>
-            <a:ext cx="3904488" cy="256032"/>
+            <a:off x="3557016" y="5358384"/>
+            <a:ext cx="3904488" cy="347472"/>
           </a:xfrm>
           <a:prstGeom prst="rect">
             <a:avLst/>
@@ -9677,11 +9677,11 @@
           <a:p>
             <a:pPr algn="ctr">
               <a:lnSpc>
-                <a:spcPct val="100000"/>
+                <a:spcPct val="105000"/>
               </a:lnSpc>
             </a:pPr>
             <a:r>
-              <a:rPr sz="1050" b="0">
+              <a:rPr sz="950" b="0">
                 <a:solidFill>
                   <a:srgbClr val="333A44"/>
                 </a:solidFill>
@@ -10743,7 +10743,7 @@
               </a:lnSpc>
             </a:pPr>
             <a:r>
-              <a:rPr sz="1050" b="0">
+              <a:rPr sz="1000" b="0">
                 <a:solidFill>
                   <a:srgbClr val="6B7688"/>
                 </a:solidFill>
@@ -10824,13 +10824,13 @@
               </a:lnSpc>
             </a:pPr>
             <a:r>
-              <a:rPr sz="1050" b="0">
+              <a:rPr sz="1000" b="0">
                 <a:solidFill>
                   <a:srgbClr val="6B7688"/>
                 </a:solidFill>
                 <a:latin typeface="Segoe UI"/>
               </a:rPr>
-              <a:t>Khám phá dữ liệu</a:t>
+              <a:t>Insight doanh nghiệp</a:t>
             </a:r>
           </a:p>
         </p:txBody>
@@ -10849,7 +10849,9 @@
           <a:prstGeom prst="rect">
             <a:avLst/>
           </a:prstGeom>
-          <a:noFill/>
+          <a:solidFill>
+            <a:srgbClr val="11161F"/>
+          </a:solidFill>
           <a:ln>
             <a:noFill/>
           </a:ln>
@@ -10879,7 +10881,51 @@
       </p:sp>
       <p:sp>
         <p:nvSpPr>
-          <p:cNvPr id="20" name="TextBox 19"/>
+          <p:cNvPr id="20" name="Rectangle 19"/>
+          <p:cNvSpPr/>
+          <p:nvPr/>
+        </p:nvSpPr>
+        <p:spPr>
+          <a:xfrm>
+            <a:off x="4023360" y="2020824"/>
+            <a:ext cx="1645920" cy="27940"/>
+          </a:xfrm>
+          <a:prstGeom prst="rect">
+            <a:avLst/>
+          </a:prstGeom>
+          <a:solidFill>
+            <a:srgbClr val="F4D35E"/>
+          </a:solidFill>
+          <a:ln>
+            <a:noFill/>
+          </a:ln>
+          <a:effectLst/>
+        </p:spPr>
+        <p:style>
+          <a:lnRef idx="1">
+            <a:schemeClr val="accent1"/>
+          </a:lnRef>
+          <a:fillRef idx="3">
+            <a:schemeClr val="accent1"/>
+          </a:fillRef>
+          <a:effectRef idx="2">
+            <a:schemeClr val="accent1"/>
+          </a:effectRef>
+          <a:fontRef idx="minor">
+            <a:schemeClr val="lt1"/>
+          </a:fontRef>
+        </p:style>
+        <p:txBody>
+          <a:bodyPr rtlCol="0" anchor="ctr"/>
+          <a:lstStyle/>
+          <a:p>
+            <a:pPr algn="ctr"/>
+          </a:p>
+        </p:txBody>
+      </p:sp>
+      <p:sp>
+        <p:nvSpPr>
+          <p:cNvPr id="21" name="TextBox 20"/>
           <p:cNvSpPr txBox="1"/>
           <p:nvPr/>
         </p:nvSpPr>
@@ -10905,20 +10951,20 @@
               </a:lnSpc>
             </a:pPr>
             <a:r>
-              <a:rPr sz="1050" b="0">
-                <a:solidFill>
-                  <a:srgbClr val="6B7688"/>
+              <a:rPr sz="1000" b="1">
+                <a:solidFill>
+                  <a:srgbClr val="F1F5F9"/>
                 </a:solidFill>
                 <a:latin typeface="Segoe UI"/>
               </a:rPr>
-              <a:t>Company Insights</a:t>
-            </a:r>
-          </a:p>
-        </p:txBody>
-      </p:sp>
-      <p:sp>
-        <p:nvSpPr>
-          <p:cNvPr id="21" name="Rectangle 20"/>
+              <a:t>Phân tích review</a:t>
+            </a:r>
+          </a:p>
+        </p:txBody>
+      </p:sp>
+      <p:sp>
+        <p:nvSpPr>
+          <p:cNvPr id="22" name="Rectangle 21"/>
           <p:cNvSpPr/>
           <p:nvPr/>
         </p:nvSpPr>
@@ -10930,53 +10976,7 @@
           <a:prstGeom prst="rect">
             <a:avLst/>
           </a:prstGeom>
-          <a:solidFill>
-            <a:srgbClr val="11161F"/>
-          </a:solidFill>
-          <a:ln>
-            <a:noFill/>
-          </a:ln>
-          <a:effectLst/>
-        </p:spPr>
-        <p:style>
-          <a:lnRef idx="1">
-            <a:schemeClr val="accent1"/>
-          </a:lnRef>
-          <a:fillRef idx="3">
-            <a:schemeClr val="accent1"/>
-          </a:fillRef>
-          <a:effectRef idx="2">
-            <a:schemeClr val="accent1"/>
-          </a:effectRef>
-          <a:fontRef idx="minor">
-            <a:schemeClr val="lt1"/>
-          </a:fontRef>
-        </p:style>
-        <p:txBody>
-          <a:bodyPr rtlCol="0" anchor="ctr"/>
-          <a:lstStyle/>
-          <a:p>
-            <a:pPr algn="ctr"/>
-          </a:p>
-        </p:txBody>
-      </p:sp>
-      <p:sp>
-        <p:nvSpPr>
-          <p:cNvPr id="22" name="Rectangle 21"/>
-          <p:cNvSpPr/>
-          <p:nvPr/>
-        </p:nvSpPr>
-        <p:spPr>
-          <a:xfrm>
-            <a:off x="5760720" y="2020824"/>
-            <a:ext cx="1645920" cy="27940"/>
-          </a:xfrm>
-          <a:prstGeom prst="rect">
-            <a:avLst/>
-          </a:prstGeom>
-          <a:solidFill>
-            <a:srgbClr val="FF994F"/>
-          </a:solidFill>
+          <a:noFill/>
           <a:ln>
             <a:noFill/>
           </a:ln>
@@ -11032,13 +11032,13 @@
               </a:lnSpc>
             </a:pPr>
             <a:r>
-              <a:rPr sz="1050" b="1">
-                <a:solidFill>
-                  <a:srgbClr val="F1F5F9"/>
+              <a:rPr sz="1000" b="0">
+                <a:solidFill>
+                  <a:srgbClr val="6B7688"/>
                 </a:solidFill>
                 <a:latin typeface="Segoe UI"/>
               </a:rPr>
-              <a:t>Dự đoán Realtime</a:t>
+              <a:t>Mô hình &amp; đánh giá</a:t>
             </a:r>
           </a:p>
         </p:txBody>
@@ -11417,14 +11417,270 @@
       </p:sp>
       <p:sp>
         <p:nvSpPr>
-          <p:cNvPr id="33" name="TextBox 32"/>
+          <p:cNvPr id="33" name="Rectangle 32"/>
+          <p:cNvSpPr/>
+          <p:nvPr/>
+        </p:nvSpPr>
+        <p:spPr>
+          <a:xfrm>
+            <a:off x="822960" y="4581144"/>
+            <a:ext cx="3154680" cy="393192"/>
+          </a:xfrm>
+          <a:prstGeom prst="rect">
+            <a:avLst/>
+          </a:prstGeom>
+          <a:solidFill>
+            <a:srgbClr val="11161F"/>
+          </a:solidFill>
+          <a:ln>
+            <a:noFill/>
+          </a:ln>
+          <a:effectLst/>
+        </p:spPr>
+        <p:style>
+          <a:lnRef idx="1">
+            <a:schemeClr val="accent1"/>
+          </a:lnRef>
+          <a:fillRef idx="3">
+            <a:schemeClr val="accent1"/>
+          </a:fillRef>
+          <a:effectRef idx="2">
+            <a:schemeClr val="accent1"/>
+          </a:effectRef>
+          <a:fontRef idx="minor">
+            <a:schemeClr val="lt1"/>
+          </a:fontRef>
+        </p:style>
+        <p:txBody>
+          <a:bodyPr rtlCol="0" anchor="ctr"/>
+          <a:lstStyle/>
+          <a:p>
+            <a:pPr algn="ctr"/>
+          </a:p>
+        </p:txBody>
+      </p:sp>
+      <p:sp>
+        <p:nvSpPr>
+          <p:cNvPr id="34" name="TextBox 33"/>
           <p:cNvSpPr txBox="1"/>
           <p:nvPr/>
         </p:nvSpPr>
         <p:spPr>
           <a:xfrm>
-            <a:off x="960120" y="4645152"/>
-            <a:ext cx="6035040" cy="274320"/>
+            <a:off x="822960" y="4645152"/>
+            <a:ext cx="3154680" cy="274320"/>
+          </a:xfrm>
+          <a:prstGeom prst="rect">
+            <a:avLst/>
+          </a:prstGeom>
+          <a:noFill/>
+        </p:spPr>
+        <p:txBody>
+          <a:bodyPr wrap="square" anchor="t" lIns="0" rIns="0" tIns="0" bIns="0">
+            <a:spAutoFit/>
+          </a:bodyPr>
+          <a:lstStyle/>
+          <a:p>
+            <a:pPr algn="ctr">
+              <a:lnSpc>
+                <a:spcPct val="100000"/>
+              </a:lnSpc>
+            </a:pPr>
+            <a:r>
+              <a:rPr sz="950" b="0">
+                <a:solidFill>
+                  <a:srgbClr val="6B7688"/>
+                </a:solidFill>
+                <a:latin typeface="Segoe UI"/>
+              </a:rPr>
+              <a:t>Text-only · 5.000 chiều</a:t>
+            </a:r>
+          </a:p>
+        </p:txBody>
+      </p:sp>
+      <p:sp>
+        <p:nvSpPr>
+          <p:cNvPr id="35" name="Rectangle 34"/>
+          <p:cNvSpPr/>
+          <p:nvPr/>
+        </p:nvSpPr>
+        <p:spPr>
+          <a:xfrm>
+            <a:off x="3977640" y="4581144"/>
+            <a:ext cx="3154680" cy="393192"/>
+          </a:xfrm>
+          <a:prstGeom prst="rect">
+            <a:avLst/>
+          </a:prstGeom>
+          <a:solidFill>
+            <a:srgbClr val="527BD1"/>
+          </a:solidFill>
+          <a:ln>
+            <a:noFill/>
+          </a:ln>
+          <a:effectLst/>
+        </p:spPr>
+        <p:style>
+          <a:lnRef idx="1">
+            <a:schemeClr val="accent1"/>
+          </a:lnRef>
+          <a:fillRef idx="3">
+            <a:schemeClr val="accent1"/>
+          </a:fillRef>
+          <a:effectRef idx="2">
+            <a:schemeClr val="accent1"/>
+          </a:effectRef>
+          <a:fontRef idx="minor">
+            <a:schemeClr val="lt1"/>
+          </a:fontRef>
+        </p:style>
+        <p:txBody>
+          <a:bodyPr rtlCol="0" anchor="ctr"/>
+          <a:lstStyle/>
+          <a:p>
+            <a:pPr algn="ctr"/>
+          </a:p>
+        </p:txBody>
+      </p:sp>
+      <p:sp>
+        <p:nvSpPr>
+          <p:cNvPr id="36" name="TextBox 35"/>
+          <p:cNvSpPr txBox="1"/>
+          <p:nvPr/>
+        </p:nvSpPr>
+        <p:spPr>
+          <a:xfrm>
+            <a:off x="3977640" y="4645152"/>
+            <a:ext cx="3154680" cy="274320"/>
+          </a:xfrm>
+          <a:prstGeom prst="rect">
+            <a:avLst/>
+          </a:prstGeom>
+          <a:noFill/>
+        </p:spPr>
+        <p:txBody>
+          <a:bodyPr wrap="square" anchor="t" lIns="0" rIns="0" tIns="0" bIns="0">
+            <a:spAutoFit/>
+          </a:bodyPr>
+          <a:lstStyle/>
+          <a:p>
+            <a:pPr algn="ctr">
+              <a:lnSpc>
+                <a:spcPct val="100000"/>
+              </a:lnSpc>
+            </a:pPr>
+            <a:r>
+              <a:rPr sz="950" b="1">
+                <a:solidFill>
+                  <a:srgbClr val="FFFFFF"/>
+                </a:solidFill>
+                <a:latin typeface="Segoe UI"/>
+              </a:rPr>
+              <a:t>Text + Lexicon · 5.005 chiều</a:t>
+            </a:r>
+          </a:p>
+        </p:txBody>
+      </p:sp>
+      <p:sp>
+        <p:nvSpPr>
+          <p:cNvPr id="37" name="Rectangle 36"/>
+          <p:cNvSpPr/>
+          <p:nvPr/>
+        </p:nvSpPr>
+        <p:spPr>
+          <a:xfrm>
+            <a:off x="7680960" y="1508760"/>
+            <a:ext cx="4114800" cy="4343400"/>
+          </a:xfrm>
+          <a:prstGeom prst="rect">
+            <a:avLst/>
+          </a:prstGeom>
+          <a:solidFill>
+            <a:srgbClr val="141A24"/>
+          </a:solidFill>
+          <a:ln w="12700">
+            <a:solidFill>
+              <a:srgbClr val="242C3A"/>
+            </a:solidFill>
+          </a:ln>
+          <a:effectLst/>
+        </p:spPr>
+        <p:style>
+          <a:lnRef idx="1">
+            <a:schemeClr val="accent1"/>
+          </a:lnRef>
+          <a:fillRef idx="3">
+            <a:schemeClr val="accent1"/>
+          </a:fillRef>
+          <a:effectRef idx="2">
+            <a:schemeClr val="accent1"/>
+          </a:effectRef>
+          <a:fontRef idx="minor">
+            <a:schemeClr val="lt1"/>
+          </a:fontRef>
+        </p:style>
+        <p:txBody>
+          <a:bodyPr rtlCol="0" anchor="ctr"/>
+          <a:lstStyle/>
+          <a:p>
+            <a:pPr algn="ctr"/>
+          </a:p>
+        </p:txBody>
+      </p:sp>
+      <p:sp>
+        <p:nvSpPr>
+          <p:cNvPr id="38" name="Rectangle 37"/>
+          <p:cNvSpPr/>
+          <p:nvPr/>
+        </p:nvSpPr>
+        <p:spPr>
+          <a:xfrm>
+            <a:off x="7680960" y="1508760"/>
+            <a:ext cx="4114800" cy="45720"/>
+          </a:xfrm>
+          <a:prstGeom prst="rect">
+            <a:avLst/>
+          </a:prstGeom>
+          <a:solidFill>
+            <a:srgbClr val="7AA7FF"/>
+          </a:solidFill>
+          <a:ln>
+            <a:noFill/>
+          </a:ln>
+          <a:effectLst/>
+        </p:spPr>
+        <p:style>
+          <a:lnRef idx="1">
+            <a:schemeClr val="accent1"/>
+          </a:lnRef>
+          <a:fillRef idx="3">
+            <a:schemeClr val="accent1"/>
+          </a:fillRef>
+          <a:effectRef idx="2">
+            <a:schemeClr val="accent1"/>
+          </a:effectRef>
+          <a:fontRef idx="minor">
+            <a:schemeClr val="lt1"/>
+          </a:fontRef>
+        </p:style>
+        <p:txBody>
+          <a:bodyPr rtlCol="0" anchor="ctr"/>
+          <a:lstStyle/>
+          <a:p>
+            <a:pPr algn="ctr"/>
+          </a:p>
+        </p:txBody>
+      </p:sp>
+      <p:sp>
+        <p:nvSpPr>
+          <p:cNvPr id="39" name="TextBox 38"/>
+          <p:cNvSpPr txBox="1"/>
+          <p:nvPr/>
+        </p:nvSpPr>
+        <p:spPr>
+          <a:xfrm>
+            <a:off x="7863840" y="1655064"/>
+            <a:ext cx="3749040" cy="320040"/>
           </a:xfrm>
           <a:prstGeom prst="rect">
             <a:avLst/>
@@ -11443,73 +11699,27 @@
               </a:lnSpc>
             </a:pPr>
             <a:r>
-              <a:rPr sz="1050" b="0">
-                <a:solidFill>
-                  <a:srgbClr val="A0ADBF"/>
+              <a:rPr sz="1350" b="1">
+                <a:solidFill>
+                  <a:srgbClr val="F1F5F9"/>
                 </a:solidFill>
                 <a:latin typeface="Segoe UI"/>
               </a:rPr>
-              <a:t>○ Mô hình 1: Text-only (5.000)      ● Mô hình 2: Text + Lexicon (5.005)</a:t>
-            </a:r>
-          </a:p>
-        </p:txBody>
-      </p:sp>
-      <p:sp>
-        <p:nvSpPr>
-          <p:cNvPr id="34" name="Rectangle 33"/>
-          <p:cNvSpPr/>
-          <p:nvPr/>
-        </p:nvSpPr>
-        <p:spPr>
-          <a:xfrm>
-            <a:off x="7680960" y="1508760"/>
-            <a:ext cx="4114800" cy="4343400"/>
-          </a:xfrm>
-          <a:prstGeom prst="rect">
-            <a:avLst/>
-          </a:prstGeom>
-          <a:solidFill>
-            <a:srgbClr val="141A24"/>
-          </a:solidFill>
-          <a:ln w="12700">
-            <a:solidFill>
-              <a:srgbClr val="242C3A"/>
-            </a:solidFill>
-          </a:ln>
-          <a:effectLst/>
-        </p:spPr>
-        <p:style>
-          <a:lnRef idx="1">
-            <a:schemeClr val="accent1"/>
-          </a:lnRef>
-          <a:fillRef idx="3">
-            <a:schemeClr val="accent1"/>
-          </a:fillRef>
-          <a:effectRef idx="2">
-            <a:schemeClr val="accent1"/>
-          </a:effectRef>
-          <a:fontRef idx="minor">
-            <a:schemeClr val="lt1"/>
-          </a:fontRef>
-        </p:style>
-        <p:txBody>
-          <a:bodyPr rtlCol="0" anchor="ctr"/>
-          <a:lstStyle/>
-          <a:p>
-            <a:pPr algn="ctr"/>
-          </a:p>
-        </p:txBody>
-      </p:sp>
-      <p:sp>
-        <p:nvSpPr>
-          <p:cNvPr id="35" name="Rectangle 34"/>
-          <p:cNvSpPr/>
-          <p:nvPr/>
-        </p:nvSpPr>
-        <p:spPr>
-          <a:xfrm>
-            <a:off x="7680960" y="1508760"/>
-            <a:ext cx="4114800" cy="45720"/>
+              <a:t>4 trang chức năng trên ứng dụng</a:t>
+            </a:r>
+          </a:p>
+        </p:txBody>
+      </p:sp>
+      <p:sp>
+        <p:nvSpPr>
+          <p:cNvPr id="40" name="Rectangle 39"/>
+          <p:cNvSpPr/>
+          <p:nvPr/>
+        </p:nvSpPr>
+        <p:spPr>
+          <a:xfrm>
+            <a:off x="7882128" y="2075688"/>
+            <a:ext cx="73152" cy="777240"/>
           </a:xfrm>
           <a:prstGeom prst="rect">
             <a:avLst/>
@@ -11546,14 +11756,14 @@
       </p:sp>
       <p:sp>
         <p:nvSpPr>
-          <p:cNvPr id="36" name="TextBox 35"/>
+          <p:cNvPr id="41" name="TextBox 40"/>
           <p:cNvSpPr txBox="1"/>
           <p:nvPr/>
         </p:nvSpPr>
         <p:spPr>
           <a:xfrm>
-            <a:off x="7863840" y="1655064"/>
-            <a:ext cx="3749040" cy="320040"/>
+            <a:off x="8065008" y="2075688"/>
+            <a:ext cx="3383280" cy="256032"/>
           </a:xfrm>
           <a:prstGeom prst="rect">
             <a:avLst/>
@@ -11572,33 +11782,72 @@
               </a:lnSpc>
             </a:pPr>
             <a:r>
-              <a:rPr sz="1350" b="1">
+              <a:rPr sz="1200" b="1">
                 <a:solidFill>
                   <a:srgbClr val="F1F5F9"/>
                 </a:solidFill>
                 <a:latin typeface="Segoe UI"/>
               </a:rPr>
-              <a:t>4 phân hệ chức năng</a:t>
-            </a:r>
-          </a:p>
-        </p:txBody>
-      </p:sp>
-      <p:sp>
-        <p:nvSpPr>
-          <p:cNvPr id="37" name="Rectangle 36"/>
-          <p:cNvSpPr/>
-          <p:nvPr/>
-        </p:nvSpPr>
-        <p:spPr>
-          <a:xfrm>
-            <a:off x="7882128" y="2075688"/>
+              <a:t>Tổng quan</a:t>
+            </a:r>
+          </a:p>
+        </p:txBody>
+      </p:sp>
+      <p:sp>
+        <p:nvSpPr>
+          <p:cNvPr id="42" name="TextBox 41"/>
+          <p:cNvSpPr txBox="1"/>
+          <p:nvPr/>
+        </p:nvSpPr>
+        <p:spPr>
+          <a:xfrm>
+            <a:off x="8065008" y="2350008"/>
+            <a:ext cx="3383280" cy="457200"/>
+          </a:xfrm>
+          <a:prstGeom prst="rect">
+            <a:avLst/>
+          </a:prstGeom>
+          <a:noFill/>
+        </p:spPr>
+        <p:txBody>
+          <a:bodyPr wrap="square" anchor="t" lIns="0" rIns="0" tIns="0" bIns="0">
+            <a:spAutoFit/>
+          </a:bodyPr>
+          <a:lstStyle/>
+          <a:p>
+            <a:pPr algn="l">
+              <a:lnSpc>
+                <a:spcPct val="110000"/>
+              </a:lnSpc>
+            </a:pPr>
+            <a:r>
+              <a:rPr sz="1030" b="0">
+                <a:solidFill>
+                  <a:srgbClr val="A0ADBF"/>
+                </a:solidFill>
+                <a:latin typeface="Segoe UI"/>
+              </a:rPr>
+              <a:t>Giới thiệu pipeline, KPI dữ liệu &amp; phân bố cảm xúc toàn hệ thống.</a:t>
+            </a:r>
+          </a:p>
+        </p:txBody>
+      </p:sp>
+      <p:sp>
+        <p:nvSpPr>
+          <p:cNvPr id="43" name="Rectangle 42"/>
+          <p:cNvSpPr/>
+          <p:nvPr/>
+        </p:nvSpPr>
+        <p:spPr>
+          <a:xfrm>
+            <a:off x="7882128" y="2990088"/>
             <a:ext cx="73152" cy="777240"/>
           </a:xfrm>
           <a:prstGeom prst="rect">
             <a:avLst/>
           </a:prstGeom>
           <a:solidFill>
-            <a:srgbClr val="7AA7FF"/>
+            <a:srgbClr val="50E3A4"/>
           </a:solidFill>
           <a:ln>
             <a:noFill/>
@@ -11629,13 +11878,13 @@
       </p:sp>
       <p:sp>
         <p:nvSpPr>
-          <p:cNvPr id="38" name="TextBox 37"/>
+          <p:cNvPr id="44" name="TextBox 43"/>
           <p:cNvSpPr txBox="1"/>
           <p:nvPr/>
         </p:nvSpPr>
         <p:spPr>
           <a:xfrm>
-            <a:off x="8065008" y="2075688"/>
+            <a:off x="8065008" y="2990088"/>
             <a:ext cx="3383280" cy="256032"/>
           </a:xfrm>
           <a:prstGeom prst="rect">
@@ -11661,20 +11910,20 @@
                 </a:solidFill>
                 <a:latin typeface="Segoe UI"/>
               </a:rPr>
-              <a:t>Tổng quan dự án</a:t>
-            </a:r>
-          </a:p>
-        </p:txBody>
-      </p:sp>
-      <p:sp>
-        <p:nvSpPr>
-          <p:cNvPr id="39" name="TextBox 38"/>
+              <a:t>Insight doanh nghiệp</a:t>
+            </a:r>
+          </a:p>
+        </p:txBody>
+      </p:sp>
+      <p:sp>
+        <p:nvSpPr>
+          <p:cNvPr id="45" name="TextBox 44"/>
           <p:cNvSpPr txBox="1"/>
           <p:nvPr/>
         </p:nvSpPr>
         <p:spPr>
           <a:xfrm>
-            <a:off x="8065008" y="2350008"/>
+            <a:off x="8065008" y="3264408"/>
             <a:ext cx="3383280" cy="457200"/>
           </a:xfrm>
           <a:prstGeom prst="rect">
@@ -11700,27 +11949,27 @@
                 </a:solidFill>
                 <a:latin typeface="Segoe UI"/>
               </a:rPr>
-              <a:t>Giới thiệu pipeline, số liệu tổng hợp toàn hệ thống.</a:t>
-            </a:r>
-          </a:p>
-        </p:txBody>
-      </p:sp>
-      <p:sp>
-        <p:nvSpPr>
-          <p:cNvPr id="40" name="Rectangle 39"/>
-          <p:cNvSpPr/>
-          <p:nvPr/>
-        </p:nvSpPr>
-        <p:spPr>
-          <a:xfrm>
-            <a:off x="7882128" y="2990088"/>
+              <a:t>WordCloud &amp; thống kê cảm xúc theo từng công ty IT.</a:t>
+            </a:r>
+          </a:p>
+        </p:txBody>
+      </p:sp>
+      <p:sp>
+        <p:nvSpPr>
+          <p:cNvPr id="46" name="Rectangle 45"/>
+          <p:cNvSpPr/>
+          <p:nvPr/>
+        </p:nvSpPr>
+        <p:spPr>
+          <a:xfrm>
+            <a:off x="7882128" y="3904488"/>
             <a:ext cx="73152" cy="777240"/>
           </a:xfrm>
           <a:prstGeom prst="rect">
             <a:avLst/>
           </a:prstGeom>
           <a:solidFill>
-            <a:srgbClr val="50E3A4"/>
+            <a:srgbClr val="F4D35E"/>
           </a:solidFill>
           <a:ln>
             <a:noFill/>
@@ -11751,13 +12000,13 @@
       </p:sp>
       <p:sp>
         <p:nvSpPr>
-          <p:cNvPr id="41" name="TextBox 40"/>
+          <p:cNvPr id="47" name="TextBox 46"/>
           <p:cNvSpPr txBox="1"/>
           <p:nvPr/>
         </p:nvSpPr>
         <p:spPr>
           <a:xfrm>
-            <a:off x="8065008" y="2990088"/>
+            <a:off x="8065008" y="3904488"/>
             <a:ext cx="3383280" cy="256032"/>
           </a:xfrm>
           <a:prstGeom prst="rect">
@@ -11783,20 +12032,20 @@
                 </a:solidFill>
                 <a:latin typeface="Segoe UI"/>
               </a:rPr>
-              <a:t>Khám phá dữ liệu</a:t>
-            </a:r>
-          </a:p>
-        </p:txBody>
-      </p:sp>
-      <p:sp>
-        <p:nvSpPr>
-          <p:cNvPr id="42" name="TextBox 41"/>
+              <a:t>Phân tích review</a:t>
+            </a:r>
+          </a:p>
+        </p:txBody>
+      </p:sp>
+      <p:sp>
+        <p:nvSpPr>
+          <p:cNvPr id="48" name="TextBox 47"/>
           <p:cNvSpPr txBox="1"/>
           <p:nvPr/>
         </p:nvSpPr>
         <p:spPr>
           <a:xfrm>
-            <a:off x="8065008" y="3264408"/>
+            <a:off x="8065008" y="4178808"/>
             <a:ext cx="3383280" cy="457200"/>
           </a:xfrm>
           <a:prstGeom prst="rect">
@@ -11822,27 +12071,27 @@
                 </a:solidFill>
                 <a:latin typeface="Segoe UI"/>
               </a:rPr>
-              <a:t>EDA tương tác: phân bố nhãn, độ dài văn bản, khía cạnh.</a:t>
-            </a:r>
-          </a:p>
-        </p:txBody>
-      </p:sp>
-      <p:sp>
-        <p:nvSpPr>
-          <p:cNvPr id="43" name="Rectangle 42"/>
-          <p:cNvSpPr/>
-          <p:nvPr/>
-        </p:nvSpPr>
-        <p:spPr>
-          <a:xfrm>
-            <a:off x="7882128" y="3904488"/>
+              <a:t>Nhập review, chọn mô hình, xem kết quả kèm giải thích XAI &amp; hiệu chỉnh.</a:t>
+            </a:r>
+          </a:p>
+        </p:txBody>
+      </p:sp>
+      <p:sp>
+        <p:nvSpPr>
+          <p:cNvPr id="49" name="Rectangle 48"/>
+          <p:cNvSpPr/>
+          <p:nvPr/>
+        </p:nvSpPr>
+        <p:spPr>
+          <a:xfrm>
+            <a:off x="7882128" y="4818888"/>
             <a:ext cx="73152" cy="777240"/>
           </a:xfrm>
           <a:prstGeom prst="rect">
             <a:avLst/>
           </a:prstGeom>
           <a:solidFill>
-            <a:srgbClr val="F4D35E"/>
+            <a:srgbClr val="FF994F"/>
           </a:solidFill>
           <a:ln>
             <a:noFill/>
@@ -11873,13 +12122,13 @@
       </p:sp>
       <p:sp>
         <p:nvSpPr>
-          <p:cNvPr id="44" name="TextBox 43"/>
+          <p:cNvPr id="50" name="TextBox 49"/>
           <p:cNvSpPr txBox="1"/>
           <p:nvPr/>
         </p:nvSpPr>
         <p:spPr>
           <a:xfrm>
-            <a:off x="8065008" y="3904488"/>
+            <a:off x="8065008" y="4818888"/>
             <a:ext cx="3383280" cy="256032"/>
           </a:xfrm>
           <a:prstGeom prst="rect">
@@ -11905,20 +12154,20 @@
                 </a:solidFill>
                 <a:latin typeface="Segoe UI"/>
               </a:rPr>
-              <a:t>Phân tích doanh nghiệp</a:t>
-            </a:r>
-          </a:p>
-        </p:txBody>
-      </p:sp>
-      <p:sp>
-        <p:nvSpPr>
-          <p:cNvPr id="45" name="TextBox 44"/>
+              <a:t>Mô hình &amp; đánh giá</a:t>
+            </a:r>
+          </a:p>
+        </p:txBody>
+      </p:sp>
+      <p:sp>
+        <p:nvSpPr>
+          <p:cNvPr id="51" name="TextBox 50"/>
           <p:cNvSpPr txBox="1"/>
           <p:nvPr/>
         </p:nvSpPr>
         <p:spPr>
           <a:xfrm>
-            <a:off x="8065008" y="4178808"/>
+            <a:off x="8065008" y="5093208"/>
             <a:ext cx="3383280" cy="457200"/>
           </a:xfrm>
           <a:prstGeom prst="rect">
@@ -11944,129 +12193,7 @@
                 </a:solidFill>
                 <a:latin typeface="Segoe UI"/>
               </a:rPr>
-              <a:t>WordCloud &amp; thống kê cảm xúc theo từng công ty IT.</a:t>
-            </a:r>
-          </a:p>
-        </p:txBody>
-      </p:sp>
-      <p:sp>
-        <p:nvSpPr>
-          <p:cNvPr id="46" name="Rectangle 45"/>
-          <p:cNvSpPr/>
-          <p:nvPr/>
-        </p:nvSpPr>
-        <p:spPr>
-          <a:xfrm>
-            <a:off x="7882128" y="4818888"/>
-            <a:ext cx="73152" cy="777240"/>
-          </a:xfrm>
-          <a:prstGeom prst="rect">
-            <a:avLst/>
-          </a:prstGeom>
-          <a:solidFill>
-            <a:srgbClr val="FF994F"/>
-          </a:solidFill>
-          <a:ln>
-            <a:noFill/>
-          </a:ln>
-          <a:effectLst/>
-        </p:spPr>
-        <p:style>
-          <a:lnRef idx="1">
-            <a:schemeClr val="accent1"/>
-          </a:lnRef>
-          <a:fillRef idx="3">
-            <a:schemeClr val="accent1"/>
-          </a:fillRef>
-          <a:effectRef idx="2">
-            <a:schemeClr val="accent1"/>
-          </a:effectRef>
-          <a:fontRef idx="minor">
-            <a:schemeClr val="lt1"/>
-          </a:fontRef>
-        </p:style>
-        <p:txBody>
-          <a:bodyPr rtlCol="0" anchor="ctr"/>
-          <a:lstStyle/>
-          <a:p>
-            <a:pPr algn="ctr"/>
-          </a:p>
-        </p:txBody>
-      </p:sp>
-      <p:sp>
-        <p:nvSpPr>
-          <p:cNvPr id="47" name="TextBox 46"/>
-          <p:cNvSpPr txBox="1"/>
-          <p:nvPr/>
-        </p:nvSpPr>
-        <p:spPr>
-          <a:xfrm>
-            <a:off x="8065008" y="4818888"/>
-            <a:ext cx="3383280" cy="256032"/>
-          </a:xfrm>
-          <a:prstGeom prst="rect">
-            <a:avLst/>
-          </a:prstGeom>
-          <a:noFill/>
-        </p:spPr>
-        <p:txBody>
-          <a:bodyPr wrap="square" anchor="t" lIns="0" rIns="0" tIns="0" bIns="0">
-            <a:spAutoFit/>
-          </a:bodyPr>
-          <a:lstStyle/>
-          <a:p>
-            <a:pPr algn="l">
-              <a:lnSpc>
-                <a:spcPct val="100000"/>
-              </a:lnSpc>
-            </a:pPr>
-            <a:r>
-              <a:rPr sz="1200" b="1">
-                <a:solidFill>
-                  <a:srgbClr val="F1F5F9"/>
-                </a:solidFill>
-                <a:latin typeface="Segoe UI"/>
-              </a:rPr>
-              <a:t>Dự đoán thời gian thực</a:t>
-            </a:r>
-          </a:p>
-        </p:txBody>
-      </p:sp>
-      <p:sp>
-        <p:nvSpPr>
-          <p:cNvPr id="48" name="TextBox 47"/>
-          <p:cNvSpPr txBox="1"/>
-          <p:nvPr/>
-        </p:nvSpPr>
-        <p:spPr>
-          <a:xfrm>
-            <a:off x="8065008" y="5093208"/>
-            <a:ext cx="3383280" cy="457200"/>
-          </a:xfrm>
-          <a:prstGeom prst="rect">
-            <a:avLst/>
-          </a:prstGeom>
-          <a:noFill/>
-        </p:spPr>
-        <p:txBody>
-          <a:bodyPr wrap="square" anchor="t" lIns="0" rIns="0" tIns="0" bIns="0">
-            <a:spAutoFit/>
-          </a:bodyPr>
-          <a:lstStyle/>
-          <a:p>
-            <a:pPr algn="l">
-              <a:lnSpc>
-                <a:spcPct val="110000"/>
-              </a:lnSpc>
-            </a:pPr>
-            <a:r>
-              <a:rPr sz="1030" b="0">
-                <a:solidFill>
-                  <a:srgbClr val="A0ADBF"/>
-                </a:solidFill>
-                <a:latin typeface="Segoe UI"/>
-              </a:rPr>
-              <a:t>Nhập review, chọn mô hình, xem kết quả kèm giải thích XAI.</a:t>
+              <a:t>Leaderboard 5 mô hình, ma trận nhầm lẫn &amp; phân tích độ nhạy ngưỡng 30%.</a:t>
             </a:r>
           </a:p>
         </p:txBody>
@@ -13412,13 +13539,13 @@
               </a:lnSpc>
             </a:pPr>
             <a:r>
-              <a:rPr sz="1080" b="0">
+              <a:rPr sz="1050" b="0">
                 <a:solidFill>
                   <a:srgbClr val="A0ADBF"/>
                 </a:solidFill>
                 <a:latin typeface="Segoe UI"/>
               </a:rPr>
-              <a:t>Mỗi thanh thể hiện mức đóng góp của từ/cụm từ vào quyết định cuối cùng — âm (đỏ) kéo về Tiêu cực, dương (xanh) kéo về Tích cực.</a:t>
+              <a:t>Mỗi thanh thể hiện trọng số TF-IDF nổi bật của từ/cụm từ trong đầu vào — âm (đỏ) nghiêng về Tiêu cực, dương (xanh) nghiêng về Tích cực (chưa triển khai SHAP/LIME).</a:t>
             </a:r>
           </a:p>
         </p:txBody>
@@ -13722,7 +13849,7 @@
                 </a:solidFill>
                 <a:latin typeface="Segoe UI"/>
               </a:rPr>
-              <a:t>Bóc tách 3 cụm từ ảnh hưởng nhất: </a:t>
+              <a:t>Bóc tách 3 cụm từ phủ định: </a:t>
             </a:r>
             <a:r>
               <a:rPr sz="1200" b="0">
@@ -14906,7 +15033,7 @@
                 </a:solidFill>
                 <a:latin typeface="Segoe UI"/>
               </a:rPr>
-              <a:t>Web App Streamlit realtime tích hợp XAI, 43/43 unit test pass.</a:t>
+              <a:t>Web App Streamlit realtime tích hợp XAI, 55 bài kiểm thử passed.</a:t>
             </a:r>
           </a:p>
         </p:txBody>
@@ -17216,7 +17343,7 @@
                 </a:solidFill>
                 <a:latin typeface="Segoe UI"/>
               </a:rPr>
-              <a:t>NHÓM 4 SẴN SÀNG BƯỚC VÀO</a:t>
+              <a:t>TIẾP THEO BƯỚC VÀO</a:t>
             </a:r>
           </a:p>
         </p:txBody>
@@ -17230,7 +17357,7 @@
         <p:spPr>
           <a:xfrm>
             <a:off x="7360920" y="4636008"/>
-            <a:ext cx="3886200" cy="731520"/>
+            <a:ext cx="3886200" cy="640080"/>
           </a:xfrm>
           <a:prstGeom prst="rect">
             <a:avLst/>
@@ -17249,13 +17376,13 @@
               </a:lnSpc>
             </a:pPr>
             <a:r>
-              <a:rPr sz="2400" b="1">
+              <a:rPr sz="2200" b="1">
                 <a:solidFill>
                   <a:srgbClr val="F1F5F9"/>
                 </a:solidFill>
                 <a:latin typeface="Segoe UI"/>
               </a:rPr>
-              <a:t>PHẦN HỎI ĐÁP (Q&amp;A)</a:t>
+              <a:t>DEMO TRỰC TIẾP</a:t>
             </a:r>
           </a:p>
         </p:txBody>
@@ -17294,7 +17421,7 @@
                 </a:solidFill>
                 <a:latin typeface="Segoe UI"/>
               </a:rPr>
-              <a:t>Trân trọng cảm ơn!</a:t>
+              <a:t>Phạm Thành Trung trình bày</a:t>
             </a:r>
           </a:p>
         </p:txBody>
@@ -20750,7 +20877,7 @@
                 </a:solidFill>
                 <a:latin typeface="Segoe UI"/>
               </a:rPr>
-              <a:t>Toàn bộ pipeline được đóng gói dạng module tái sử dụng, kiểm chứng bằng 43/43 unit test — bảo đảm nhất quán giữa notebook nghiên cứu và ứng dụng Web.</a:t>
+              <a:t>Toàn bộ pipeline được đóng gói dạng module tái sử dụng, kiểm chứng bằng 55 bài kiểm thử (test passed) — bảo đảm nhất quán giữa notebook nghiên cứu và ứng dụng Web.</a:t>
             </a:r>
           </a:p>
         </p:txBody>
@@ -21122,7 +21249,7 @@
                 </a:solidFill>
                 <a:latin typeface="Segoe UI"/>
               </a:rPr>
-              <a:t>Radio chọn Text-only (5.000) hoặc Text+Lexicon (5.005) chiều.</a:t>
+              <a:t>Segmented control chọn Text-only (5.000) hoặc Text+Lexicon (5.005) chiều.</a:t>
             </a:r>
           </a:p>
         </p:txBody>
@@ -23791,8 +23918,8 @@
         </p:nvSpPr>
         <p:spPr>
           <a:xfrm>
-            <a:off x="630936" y="5559552"/>
-            <a:ext cx="3355848" cy="256032"/>
+            <a:off x="630936" y="5449824"/>
+            <a:ext cx="3355848" cy="347472"/>
           </a:xfrm>
           <a:prstGeom prst="rect">
             <a:avLst/>
@@ -23807,11 +23934,11 @@
           <a:p>
             <a:pPr algn="ctr">
               <a:lnSpc>
-                <a:spcPct val="100000"/>
+                <a:spcPct val="105000"/>
               </a:lnSpc>
             </a:pPr>
             <a:r>
-              <a:rPr sz="1050" b="0">
+              <a:rPr sz="950" b="0">
                 <a:solidFill>
                   <a:srgbClr val="333A44"/>
                 </a:solidFill>
@@ -23900,8 +24027,8 @@
         </p:nvSpPr>
         <p:spPr>
           <a:xfrm>
-            <a:off x="4407408" y="5559552"/>
-            <a:ext cx="3355848" cy="256032"/>
+            <a:off x="4407408" y="5449824"/>
+            <a:ext cx="3355848" cy="347472"/>
           </a:xfrm>
           <a:prstGeom prst="rect">
             <a:avLst/>
@@ -23916,11 +24043,11 @@
           <a:p>
             <a:pPr algn="ctr">
               <a:lnSpc>
-                <a:spcPct val="100000"/>
+                <a:spcPct val="105000"/>
               </a:lnSpc>
             </a:pPr>
             <a:r>
-              <a:rPr sz="1050" b="0">
+              <a:rPr sz="950" b="0">
                 <a:solidFill>
                   <a:srgbClr val="333A44"/>
                 </a:solidFill>
@@ -24009,8 +24136,8 @@
         </p:nvSpPr>
         <p:spPr>
           <a:xfrm>
-            <a:off x="8183880" y="5559552"/>
-            <a:ext cx="3355848" cy="256032"/>
+            <a:off x="8183880" y="5449824"/>
+            <a:ext cx="3355848" cy="347472"/>
           </a:xfrm>
           <a:prstGeom prst="rect">
             <a:avLst/>
@@ -24025,11 +24152,11 @@
           <a:p>
             <a:pPr algn="ctr">
               <a:lnSpc>
-                <a:spcPct val="100000"/>
+                <a:spcPct val="105000"/>
               </a:lnSpc>
             </a:pPr>
             <a:r>
-              <a:rPr sz="1050" b="0">
+              <a:rPr sz="950" b="0">
                 <a:solidFill>
                   <a:srgbClr val="333A44"/>
                 </a:solidFill>
@@ -24648,8 +24775,8 @@
         </p:nvSpPr>
         <p:spPr>
           <a:xfrm>
-            <a:off x="630936" y="5559552"/>
-            <a:ext cx="6236208" cy="256032"/>
+            <a:off x="630936" y="5449824"/>
+            <a:ext cx="6236208" cy="347472"/>
           </a:xfrm>
           <a:prstGeom prst="rect">
             <a:avLst/>
@@ -24664,11 +24791,11 @@
           <a:p>
             <a:pPr algn="ctr">
               <a:lnSpc>
-                <a:spcPct val="100000"/>
+                <a:spcPct val="105000"/>
               </a:lnSpc>
             </a:pPr>
             <a:r>
-              <a:rPr sz="1050" b="0">
+              <a:rPr sz="950" b="0">
                 <a:solidFill>
                   <a:srgbClr val="333A44"/>
                 </a:solidFill>
@@ -25186,7 +25313,7 @@
                 </a:solidFill>
                 <a:latin typeface="Segoe UI"/>
               </a:rPr>
-              <a:t>Dù Text+Aspect đạt Macro F1 0.7369, đặc trưng này gần trùng nhãn mục tiêu → rủi ro Data Shortcut, không phản ánh khả năng hiểu ngôn ngữ thật của mô hình.</a:t>
+              <a:t>Dù Text+Aspect đạt Macro F1 0.7433, đặc trưng này gần trùng nhãn mục tiêu → rủi ro Data Shortcut, không phản ánh khả năng hiểu ngôn ngữ thật của mô hình.</a:t>
             </a:r>
           </a:p>
         </p:txBody>
@@ -30523,8 +30650,8 @@
         </p:nvSpPr>
         <p:spPr>
           <a:xfrm>
-            <a:off x="6803136" y="5559552"/>
-            <a:ext cx="4773168" cy="256032"/>
+            <a:off x="6803136" y="5449824"/>
+            <a:ext cx="4773168" cy="347472"/>
           </a:xfrm>
           <a:prstGeom prst="rect">
             <a:avLst/>
@@ -30539,11 +30666,11 @@
           <a:p>
             <a:pPr algn="ctr">
               <a:lnSpc>
-                <a:spcPct val="100000"/>
+                <a:spcPct val="105000"/>
               </a:lnSpc>
             </a:pPr>
             <a:r>
-              <a:rPr sz="1050" b="0">
+              <a:rPr sz="950" b="0">
                 <a:solidFill>
                   <a:srgbClr val="333A44"/>
                 </a:solidFill>

</xml_diff>